<commit_message>
Upgrade to V3.0: Migrated from SVM to MLP (Deep Neural Network) | 98.43% Accuracy
</commit_message>
<xml_diff>
--- a/SecondReview.pptx
+++ b/SecondReview.pptx
@@ -222,7 +222,7 @@
             <a:fld id="{D9506F13-F2CA-4EB2-8564-AF15C019D995}" type="datetimeFigureOut">
               <a:rPr lang="en-US" smtClean="0"/>
               <a:pPr/>
-              <a:t>3/13/2026</a:t>
+              <a:t>3/23/2026</a:t>
             </a:fld>
             <a:endParaRPr lang="en-US"/>
           </a:p>
@@ -2528,7 +2528,11 @@
             </a:r>
             <a:r>
               <a:rPr lang="en-US" dirty="0"/>
-              <a:t> TF-IDF + Logistic Regression (Balanced Class Weights)</a:t>
+              <a:t> </a:t>
+            </a:r>
+            <a:r>
+              <a:rPr lang="en-IN" dirty="0"/>
+              <a:t>TF-IDF + Deep Neural Network (MLP)</a:t>
             </a:r>
           </a:p>
           <a:p>
@@ -2539,7 +2543,7 @@
             </a:r>
             <a:r>
               <a:rPr lang="en-IN" dirty="0"/>
-              <a:t> 96.76%</a:t>
+              <a:t> 98.43%</a:t>
             </a:r>
             <a:r>
               <a:rPr lang="en-US" dirty="0"/>
@@ -2554,7 +2558,7 @@
             </a:r>
             <a:r>
               <a:rPr lang="en-US" dirty="0"/>
-              <a:t> High Recall (90%) for enhanced scam detection</a:t>
+              <a:t> High Precision (89%) to minimize false alarms</a:t>
             </a:r>
           </a:p>
           <a:p>
@@ -3034,7 +3038,7 @@
             </a:r>
             <a:r>
               <a:rPr lang="en-IN" sz="2400" dirty="0"/>
-              <a:t>: 98.21%</a:t>
+              <a:t>: 98.43%</a:t>
             </a:r>
           </a:p>
           <a:p>
@@ -3048,7 +3052,7 @@
             </a:r>
             <a:r>
               <a:rPr lang="en-IN" sz="2400" dirty="0"/>
-              <a:t> 84%</a:t>
+              <a:t> 77%</a:t>
             </a:r>
           </a:p>
           <a:p>
@@ -3062,7 +3066,7 @@
             </a:r>
             <a:r>
               <a:rPr lang="en-IN" sz="2400" dirty="0"/>
-              <a:t> 80%</a:t>
+              <a:t> 89%</a:t>
             </a:r>
           </a:p>
           <a:p>
@@ -3076,7 +3080,7 @@
             </a:r>
             <a:r>
               <a:rPr lang="en-IN" sz="2400" dirty="0"/>
-              <a:t> 82%</a:t>
+              <a:t> 83%</a:t>
             </a:r>
           </a:p>
         </p:txBody>
@@ -3229,7 +3233,11 @@
                 <a:latin typeface="Times New Roman" pitchFamily="18" charset="0"/>
                 <a:cs typeface="Times New Roman" pitchFamily="18" charset="0"/>
               </a:rPr>
-              <a:t> Scikit-learn (for TF-IDF &amp; SVM Model)</a:t>
+              <a:t> </a:t>
+            </a:r>
+            <a:r>
+              <a:rPr lang="en-US" dirty="0"/>
+              <a:t>Scikit-learn (for TF-IDF &amp; Deep Neural Network / MLP)</a:t>
             </a:r>
           </a:p>
           <a:p>
@@ -4657,14 +4665,22 @@
             <a:pPr algn="just"/>
             <a:r>
               <a:rPr lang="en-US" dirty="0"/>
-              <a:t>To maximize Recall rates to ensure zero-tolerance for undetected scams</a:t>
+              <a:t>To maximize Precision (89%) to ensure minimal false alarms for legitimate postings.</a:t>
             </a:r>
           </a:p>
           <a:p>
             <a:pPr algn="just"/>
             <a:r>
-              <a:rPr lang="en-US"/>
-              <a:t>To deploy a real-time web interface (Streamlit) for instant job verification.</a:t>
+              <a:rPr lang="en-US" dirty="0"/>
+              <a:t>To deploy a real-time web interface (</a:t>
+            </a:r>
+            <a:r>
+              <a:rPr lang="en-US" dirty="0" err="1"/>
+              <a:t>Streamlit</a:t>
+            </a:r>
+            <a:r>
+              <a:rPr lang="en-US" dirty="0"/>
+              <a:t>) for instant job verification.</a:t>
             </a:r>
           </a:p>
           <a:p>
@@ -4936,7 +4952,7 @@
         </p:blipFill>
         <p:spPr>
           <a:xfrm>
-            <a:off x="1697941" y="1549699"/>
+            <a:off x="1697940" y="1549699"/>
             <a:ext cx="8796119" cy="4801788"/>
           </a:xfrm>
           <a:prstGeom prst="rect">
@@ -5037,15 +5053,7 @@
           <a:p>
             <a:r>
               <a:rPr lang="en-US" sz="2400" dirty="0"/>
-              <a:t>Model Training: Support Vector Machine (</a:t>
-            </a:r>
-            <a:r>
-              <a:rPr lang="en-US" sz="2400" dirty="0" err="1"/>
-              <a:t>LinearSVC</a:t>
-            </a:r>
-            <a:r>
-              <a:rPr lang="en-US" sz="2400" dirty="0"/>
-              <a:t>) with Balanced Class Weights.</a:t>
+              <a:t>Model Training: Model Training: Deep Neural Network (MLP) with Adam Optimizer.</a:t>
             </a:r>
           </a:p>
           <a:p>
@@ -5371,8 +5379,8 @@
           </a:p>
         </p:txBody>
       </p:sp>
-      <mc:AlternateContent xmlns:mc="http://schemas.openxmlformats.org/markup-compatibility/2006">
-        <mc:Choice xmlns:a14="http://schemas.microsoft.com/office/drawing/2010/main" Requires="a14">
+      <mc:AlternateContent xmlns:mc="http://schemas.openxmlformats.org/markup-compatibility/2006" xmlns:a14="http://schemas.microsoft.com/office/drawing/2010/main">
+        <mc:Choice Requires="a14">
           <p:sp>
             <p:nvSpPr>
               <p:cNvPr id="3" name="Content Placeholder 2"/>
@@ -5619,14 +5627,7 @@
                         <a:latin typeface="Cambria Math" panose="02040503050406030204" pitchFamily="18" charset="0"/>
                         <a:cs typeface="Times New Roman" pitchFamily="18" charset="0"/>
                       </a:rPr>
-                      <m:t>𝑇</m:t>
-                    </m:r>
-                    <m:r>
-                      <a:rPr lang="en-US" sz="2000" b="0" i="1" smtClean="0">
-                        <a:latin typeface="Cambria Math" panose="02040503050406030204" pitchFamily="18" charset="0"/>
-                        <a:cs typeface="Times New Roman" pitchFamily="18" charset="0"/>
-                      </a:rPr>
-                      <m:t>𝐹</m:t>
+                      <m:t>𝑇𝐹</m:t>
                     </m:r>
                     <m:r>
                       <a:rPr lang="en-US" sz="2000" b="0" i="1" smtClean="0">
@@ -5916,7 +5917,7 @@
             </p:txBody>
           </p:sp>
         </mc:Choice>
-        <mc:Fallback>
+        <mc:Fallback xmlns="">
           <p:sp>
             <p:nvSpPr>
               <p:cNvPr id="3" name="Content Placeholder 2"/>
@@ -6219,8 +6220,11 @@
               <a:t>            Accuracy-</a:t>
             </a:r>
             <a:r>
-              <a:rPr lang="en-IN" sz="2000" dirty="0"/>
-              <a:t> 98.21%</a:t>
+              <a:rPr lang="en-IN" sz="2000" dirty="0">
+                <a:latin typeface="Times New Roman" pitchFamily="18" charset="0"/>
+                <a:cs typeface="Times New Roman" pitchFamily="18" charset="0"/>
+              </a:rPr>
+              <a:t> 98.43%</a:t>
             </a:r>
           </a:p>
           <a:p>
@@ -6236,7 +6240,7 @@
             </a:r>
             <a:r>
               <a:rPr lang="en-IN" sz="2000" dirty="0"/>
-              <a:t> 80%</a:t>
+              <a:t> 89%</a:t>
             </a:r>
             <a:endParaRPr lang="en-US" sz="2000" dirty="0">
               <a:latin typeface="Times New Roman" pitchFamily="18" charset="0"/>
@@ -6256,7 +6260,7 @@
             </a:r>
             <a:r>
               <a:rPr lang="en-IN" sz="2000" dirty="0"/>
-              <a:t> 84%</a:t>
+              <a:t> 77%</a:t>
             </a:r>
             <a:endParaRPr lang="en-US" sz="2000" dirty="0">
               <a:latin typeface="Times New Roman" pitchFamily="18" charset="0"/>
@@ -6276,7 +6280,7 @@
             </a:r>
             <a:r>
               <a:rPr lang="en-IN" sz="2000" dirty="0"/>
-              <a:t> 82%</a:t>
+              <a:t> 83%</a:t>
             </a:r>
             <a:endParaRPr lang="en-US" sz="2000" dirty="0">
               <a:latin typeface="Times New Roman" pitchFamily="18" charset="0"/>
@@ -6369,7 +6373,7 @@
           <p:nvPr>
             <p:extLst>
               <p:ext uri="{D42A27DB-BD31-4B8C-83A1-F6EECF244321}">
-                <p14:modId xmlns:p14="http://schemas.microsoft.com/office/powerpoint/2010/main" val="401691459"/>
+                <p14:modId xmlns:p14="http://schemas.microsoft.com/office/powerpoint/2010/main" val="2119652172"/>
               </p:ext>
             </p:extLst>
           </p:nvPr>
@@ -6499,14 +6503,27 @@
                     <a:bodyPr/>
                     <a:lstStyle/>
                     <a:p>
+                      <a:pPr marL="0" marR="0" lvl="0" indent="0" algn="l" defTabSz="914400" rtl="0" eaLnBrk="1" fontAlgn="auto" latinLnBrk="0" hangingPunct="1">
+                        <a:lnSpc>
+                          <a:spcPct val="100000"/>
+                        </a:lnSpc>
+                        <a:spcBef>
+                          <a:spcPts val="0"/>
+                        </a:spcBef>
+                        <a:spcAft>
+                          <a:spcPts val="0"/>
+                        </a:spcAft>
+                        <a:buClrTx/>
+                        <a:buSzTx/>
+                        <a:buFontTx/>
+                        <a:buNone/>
+                        <a:tabLst/>
+                        <a:defRPr/>
+                      </a:pPr>
                       <a:r>
-                        <a:rPr lang="en-IN" sz="2400" dirty="0"/>
-                        <a:t>3367</a:t>
+                        <a:rPr lang="en-IN" sz="2400" b="0" dirty="0"/>
+                        <a:t>3386</a:t>
                       </a:r>
-                      <a:endParaRPr lang="en-US" sz="2400" dirty="0">
-                        <a:latin typeface="Times New Roman" pitchFamily="18" charset="0"/>
-                        <a:cs typeface="Times New Roman" pitchFamily="18" charset="0"/>
-                      </a:endParaRPr>
                     </a:p>
                   </a:txBody>
                   <a:tcPr/>
@@ -6517,12 +6534,8 @@
                     <a:lstStyle/>
                     <a:p>
                       <a:r>
-                        <a:rPr lang="en-IN" sz="2400" b="0" dirty="0"/>
-                        <a:t>36</a:t>
-                      </a:r>
-                      <a:r>
                         <a:rPr lang="en-IN" sz="2400" dirty="0"/>
-                        <a:t> </a:t>
+                        <a:t>17 </a:t>
                       </a:r>
                       <a:endParaRPr lang="en-US" sz="2400" kern="1200" dirty="0">
                         <a:solidFill>
@@ -6576,7 +6589,7 @@
                     <a:p>
                       <a:r>
                         <a:rPr lang="en-IN" sz="2400" dirty="0"/>
-                        <a:t>28</a:t>
+                        <a:t>39</a:t>
                       </a:r>
                       <a:endParaRPr lang="en-US" sz="2400" kern="1200" dirty="0">
                         <a:solidFill>
@@ -6597,7 +6610,7 @@
                     <a:p>
                       <a:r>
                         <a:rPr lang="en-IN" sz="2400" dirty="0"/>
-                        <a:t>145</a:t>
+                        <a:t>134</a:t>
                       </a:r>
                       <a:endParaRPr lang="en-US" sz="2400" kern="1200" dirty="0">
                         <a:solidFill>

</xml_diff>